<commit_message>
Real links in all documents, live checks, Compare fix, final guides
Co-Authored-By: Claude Sonnet 5.5 <noreply@anthropic.com>
</commit_message>
<xml_diff>
--- a/deliverables/Team_05_25BDS0318_25BDS0308_Final_PPT.pptx
+++ b/deliverables/Team_05_25BDS0318_25BDS0308_Final_PPT.pptx
@@ -10192,7 +10192,7 @@
                   <a:srgbClr val="1B1F3B"/>
                 </a:solidFill>
               </a:rPr>
-              <a:t>GitHub: [GitHub Link]</a:t>
+              <a:t>GitHub: https://github.com/Nithin-ASK/Team_05_25BDS0318_25BDS0308_SonicAtlas</a:t>
             </a:r>
             <a:endParaRPr lang="en-US" sz="1400" dirty="0"/>
           </a:p>
@@ -10210,7 +10210,7 @@
                   <a:srgbClr val="1B1F3B"/>
                 </a:solidFill>
               </a:rPr>
-              <a:t>Live: [Live Website Link]</a:t>
+              <a:t>Live: https://nithin-ask.github.io/Team_05_25BDS0318_25BDS0308_SonicAtlas/</a:t>
             </a:r>
             <a:endParaRPr lang="en-US" sz="1400" dirty="0"/>
           </a:p>

</xml_diff>